<commit_message>
feat: implement backend server with secure IPFS file uploading, admin analytics, and demo user seeding scripts
</commit_message>
<xml_diff>
--- a/docs/reviews/Review 2/CareChain_Review2_Presentation.pptx
+++ b/docs/reviews/Review 2/CareChain_Review2_Presentation.pptx
@@ -209,7 +209,7 @@
           <a:p>
             <a:fld id="{C058E2E1-8886-43B2-B986-F2B06DAA2FAC}" type="datetimeFigureOut">
               <a:rPr lang="en-IN" smtClean="0"/>
-              <a:t>22-08-2026</a:t>
+              <a:t>01-09-2026</a:t>
             </a:fld>
             <a:endParaRPr lang="en-IN"/>
           </a:p>
@@ -626,7 +626,7 @@
           <a:p>
             <a:fld id="{8F3E78AE-7F97-4550-9DD8-BF69171FDC30}" type="datetime1">
               <a:rPr lang="en-IN" smtClean="0"/>
-              <a:t>22-08-2026</a:t>
+              <a:t>01-09-2026</a:t>
             </a:fld>
             <a:endParaRPr lang="en-IN"/>
           </a:p>
@@ -829,7 +829,7 @@
           <a:p>
             <a:fld id="{5576931C-EA1A-43DD-B3B3-66F5BA587712}" type="datetime1">
               <a:rPr lang="en-IN" smtClean="0"/>
-              <a:t>22-08-2026</a:t>
+              <a:t>01-09-2026</a:t>
             </a:fld>
             <a:endParaRPr lang="en-IN"/>
           </a:p>
@@ -1042,7 +1042,7 @@
           <a:p>
             <a:fld id="{82C9B0E1-7C95-4C20-B9C6-BA51F388E878}" type="datetime1">
               <a:rPr lang="en-IN" smtClean="0"/>
-              <a:t>22-08-2026</a:t>
+              <a:t>01-09-2026</a:t>
             </a:fld>
             <a:endParaRPr lang="en-IN"/>
           </a:p>
@@ -1245,7 +1245,7 @@
           <a:p>
             <a:fld id="{FEA886FF-1BA7-4533-94E6-869CE1E2970B}" type="datetime1">
               <a:rPr lang="en-IN" smtClean="0"/>
-              <a:t>22-08-2026</a:t>
+              <a:t>01-09-2026</a:t>
             </a:fld>
             <a:endParaRPr lang="en-IN"/>
           </a:p>
@@ -1524,7 +1524,7 @@
           <a:p>
             <a:fld id="{93E22BD8-A2C4-424B-809A-C64DDCC305D9}" type="datetime1">
               <a:rPr lang="en-IN" smtClean="0"/>
-              <a:t>22-08-2026</a:t>
+              <a:t>01-09-2026</a:t>
             </a:fld>
             <a:endParaRPr lang="en-IN"/>
           </a:p>
@@ -1795,7 +1795,7 @@
           <a:p>
             <a:fld id="{B620F4BC-B3A4-46AF-9AEC-8478EF1369D5}" type="datetime1">
               <a:rPr lang="en-IN" smtClean="0"/>
-              <a:t>22-08-2026</a:t>
+              <a:t>01-09-2026</a:t>
             </a:fld>
             <a:endParaRPr lang="en-IN"/>
           </a:p>
@@ -2213,7 +2213,7 @@
           <a:p>
             <a:fld id="{4C9A2993-B405-4F4D-B968-A01C27211659}" type="datetime1">
               <a:rPr lang="en-IN" smtClean="0"/>
-              <a:t>22-08-2026</a:t>
+              <a:t>01-09-2026</a:t>
             </a:fld>
             <a:endParaRPr lang="en-IN"/>
           </a:p>
@@ -2358,7 +2358,7 @@
           <a:p>
             <a:fld id="{79378C8C-5FBB-4DD7-A06D-BE263480794B}" type="datetime1">
               <a:rPr lang="en-IN" smtClean="0"/>
-              <a:t>22-08-2026</a:t>
+              <a:t>01-09-2026</a:t>
             </a:fld>
             <a:endParaRPr lang="en-IN"/>
           </a:p>
@@ -2474,7 +2474,7 @@
           <a:p>
             <a:fld id="{31FD2985-06EC-459B-80C8-F6F4362A1C03}" type="datetime1">
               <a:rPr lang="en-IN" smtClean="0"/>
-              <a:t>22-08-2026</a:t>
+              <a:t>01-09-2026</a:t>
             </a:fld>
             <a:endParaRPr lang="en-IN"/>
           </a:p>
@@ -2790,7 +2790,7 @@
           <a:p>
             <a:fld id="{71D7E9DA-13C6-48A4-9305-B592482DE8CE}" type="datetime1">
               <a:rPr lang="en-IN" smtClean="0"/>
-              <a:t>22-08-2026</a:t>
+              <a:t>01-09-2026</a:t>
             </a:fld>
             <a:endParaRPr lang="en-IN"/>
           </a:p>
@@ -3082,7 +3082,7 @@
           <a:p>
             <a:fld id="{F45E7C4B-C575-4DCF-9B63-045662930500}" type="datetime1">
               <a:rPr lang="en-IN" smtClean="0"/>
-              <a:t>22-08-2026</a:t>
+              <a:t>01-09-2026</a:t>
             </a:fld>
             <a:endParaRPr lang="en-IN"/>
           </a:p>
@@ -3328,7 +3328,7 @@
           <a:p>
             <a:fld id="{43827C3E-786B-4150-9177-1C28966A2ADC}" type="datetime1">
               <a:rPr lang="en-IN" smtClean="0"/>
-              <a:t>22-08-2026</a:t>
+              <a:t>01-09-2026</a:t>
             </a:fld>
             <a:endParaRPr lang="en-IN"/>
           </a:p>
@@ -3806,7 +3806,7 @@
           <a:noFill/>
         </p:spPr>
         <p:txBody>
-          <a:bodyPr wrap="square" rtlCol="0" lIns="73152" rIns="73152" anchor="ctr">
+          <a:bodyPr wrap="square" lIns="73152" rIns="73152" rtlCol="0" anchor="ctr">
             <a:spAutoFit/>
           </a:bodyPr>
           <a:lstStyle/>
@@ -3890,8 +3890,8 @@
         </p:nvSpPr>
         <p:spPr>
           <a:xfrm>
-            <a:off x="2609088" y="3208471"/>
-            <a:ext cx="7071360" cy="2460809"/>
+            <a:off x="2609088" y="3763049"/>
+            <a:ext cx="7071360" cy="1351652"/>
           </a:xfrm>
           <a:prstGeom prst="rect">
             <a:avLst/>
@@ -3921,6 +3921,7 @@
               </a:defRPr>
             </a:pPr>
             <a:r>
+              <a:rPr dirty="0"/>
               <a:t>Candidate Details</a:t>
             </a:r>
             <a:endParaRPr sz="1800" dirty="0">
@@ -3941,6 +3942,7 @@
               </a:defRPr>
             </a:pPr>
             <a:r>
+              <a:rPr dirty="0"/>
               <a:t>Ashish Anil Sikaria  (23BCI0218)</a:t>
             </a:r>
           </a:p>
@@ -3957,6 +3959,7 @@
               </a:defRPr>
             </a:pPr>
             <a:r>
+              <a:rPr dirty="0"/>
               <a:t>Faculty Guide</a:t>
             </a:r>
           </a:p>
@@ -3973,6 +3976,7 @@
               </a:defRPr>
             </a:pPr>
             <a:r>
+              <a:rPr dirty="0"/>
               <a:t>Dr. Selvi M</a:t>
             </a:r>
           </a:p>
@@ -3989,23 +3993,8 @@
               </a:defRPr>
             </a:pPr>
             <a:r>
+              <a:rPr dirty="0"/>
               <a:t>Associate Professor Grade 2, SCOPE</a:t>
-            </a:r>
-          </a:p>
-          <a:p>
-            <a:pPr algn="ctr">
-              <a:spcAft>
-                <a:spcPts val="0"/>
-              </a:spcAft>
-              <a:defRPr sz="1200" b="1">
-                <a:solidFill>
-                  <a:srgbClr val="10B981"/>
-                </a:solidFill>
-                <a:latin typeface="Calibri"/>
-              </a:defRPr>
-            </a:pPr>
-            <a:r>
-              <a:t>Review 2 | Panel P071 | Venue: PRP306 | Date: 02-09-2026</a:t>
             </a:r>
           </a:p>
         </p:txBody>
@@ -5119,7 +5108,7 @@
           </a:bodyPr>
           <a:lstStyle/>
           <a:p>
-            <a:pPr marL="0" indent="0" eaLnBrk="0" fontAlgn="base" hangingPunct="0" algn="l">
+            <a:pPr marL="0" indent="0" algn="l" eaLnBrk="0" fontAlgn="base" hangingPunct="0">
               <a:lnSpc>
                 <a:spcPct val="100000"/>
               </a:lnSpc>
@@ -5427,18 +5416,18 @@
       </p:sp>
       <p:sp>
         <p:nvSpPr>
-          <p:cNvPr id="3" name="Content Placeholder 2">
-            <a:extLst>
-              <a:ext uri="{FF2B5EF4-FFF2-40B4-BE49-F238E27FC236}">
-                <a16:creationId xmlns:a16="http://schemas.microsoft.com/office/drawing/2014/main" id="{8233367C-DAD6-6E34-D21A-A981C09442F2}"/>
-              </a:ext>
-            </a:extLst>
-          </p:cNvPr>
-          <p:cNvSpPr>
-            <a:spLocks noGrp="1"/>
-          </p:cNvSpPr>
-          <p:nvPr>
-            <p:ph idx="1"/>
+          <p:cNvPr id="4" name="Date Placeholder 3">
+            <a:extLst>
+              <a:ext uri="{FF2B5EF4-FFF2-40B4-BE49-F238E27FC236}">
+                <a16:creationId xmlns:a16="http://schemas.microsoft.com/office/drawing/2014/main" id="{C7827C50-3ED3-2DB6-C227-6784C6CA9E30}"/>
+              </a:ext>
+            </a:extLst>
+          </p:cNvPr>
+          <p:cNvSpPr>
+            <a:spLocks noGrp="1"/>
+          </p:cNvSpPr>
+          <p:nvPr>
+            <p:ph type="dt" sz="half" idx="10"/>
           </p:nvPr>
         </p:nvSpPr>
         <p:spPr/>
@@ -5450,33 +5439,34 @@
               <a:spcAft>
                 <a:spcPts val="0"/>
               </a:spcAft>
-              <a:defRPr sz="1200" b="0">
-                <a:solidFill>
-                  <a:srgbClr val="1E293B"/>
-                </a:solidFill>
-                <a:latin typeface="Calibri"/>
-              </a:defRPr>
-            </a:pPr>
-            <a:r>
-              <a:t>Formal approval obtained from Guide Dr. Selvi M for Review-2 components (Verified on 31-08-2026):</a:t>
-            </a:r>
-          </a:p>
-        </p:txBody>
-      </p:sp>
-      <p:sp>
-        <p:nvSpPr>
-          <p:cNvPr id="4" name="Date Placeholder 3">
-            <a:extLst>
-              <a:ext uri="{FF2B5EF4-FFF2-40B4-BE49-F238E27FC236}">
-                <a16:creationId xmlns:a16="http://schemas.microsoft.com/office/drawing/2014/main" id="{C7827C50-3ED3-2DB6-C227-6784C6CA9E30}"/>
-              </a:ext>
-            </a:extLst>
-          </p:cNvPr>
-          <p:cNvSpPr>
-            <a:spLocks noGrp="1"/>
-          </p:cNvSpPr>
-          <p:nvPr>
-            <p:ph type="dt" sz="half" idx="10"/>
+              <a:defRPr sz="1100" b="0">
+                <a:solidFill>
+                  <a:srgbClr val="64748B"/>
+                </a:solidFill>
+                <a:latin typeface="Calibri"/>
+              </a:defRPr>
+            </a:pPr>
+            <a:r>
+              <a:t>02-09-2026</a:t>
+            </a:r>
+            <a:endParaRPr lang="en-IN" dirty="0"/>
+          </a:p>
+        </p:txBody>
+      </p:sp>
+      <p:sp>
+        <p:nvSpPr>
+          <p:cNvPr id="5" name="Footer Placeholder 4">
+            <a:extLst>
+              <a:ext uri="{FF2B5EF4-FFF2-40B4-BE49-F238E27FC236}">
+                <a16:creationId xmlns:a16="http://schemas.microsoft.com/office/drawing/2014/main" id="{56664170-792F-28F8-1C31-5F7A8D69F97E}"/>
+              </a:ext>
+            </a:extLst>
+          </p:cNvPr>
+          <p:cNvSpPr>
+            <a:spLocks noGrp="1"/>
+          </p:cNvSpPr>
+          <p:nvPr>
+            <p:ph type="ftr" sz="quarter" idx="11"/>
           </p:nvPr>
         </p:nvSpPr>
         <p:spPr/>
@@ -5484,7 +5474,7 @@
           <a:bodyPr wrap="square" lIns="73152" rIns="73152" anchor="t"/>
           <a:lstStyle/>
           <a:p>
-            <a:pPr algn="l">
+            <a:pPr algn="ctr">
               <a:spcAft>
                 <a:spcPts val="0"/>
               </a:spcAft>
@@ -5496,26 +5486,25 @@
               </a:defRPr>
             </a:pPr>
             <a:r>
-              <a:t>02-09-2026</a:t>
-            </a:r>
-            <a:endParaRPr lang="en-IN" dirty="0"/>
-          </a:p>
-        </p:txBody>
-      </p:sp>
-      <p:sp>
-        <p:nvSpPr>
-          <p:cNvPr id="5" name="Footer Placeholder 4">
-            <a:extLst>
-              <a:ext uri="{FF2B5EF4-FFF2-40B4-BE49-F238E27FC236}">
-                <a16:creationId xmlns:a16="http://schemas.microsoft.com/office/drawing/2014/main" id="{56664170-792F-28F8-1C31-5F7A8D69F97E}"/>
-              </a:ext>
-            </a:extLst>
-          </p:cNvPr>
-          <p:cNvSpPr>
-            <a:spLocks noGrp="1"/>
-          </p:cNvSpPr>
-          <p:nvPr>
-            <p:ph type="ftr" sz="quarter" idx="11"/>
+              <a:t>SCOPE</a:t>
+            </a:r>
+          </a:p>
+        </p:txBody>
+      </p:sp>
+      <p:sp>
+        <p:nvSpPr>
+          <p:cNvPr id="6" name="Slide Number Placeholder 5">
+            <a:extLst>
+              <a:ext uri="{FF2B5EF4-FFF2-40B4-BE49-F238E27FC236}">
+                <a16:creationId xmlns:a16="http://schemas.microsoft.com/office/drawing/2014/main" id="{EE16528B-72DB-0275-6A94-33ABB5CD7075}"/>
+              </a:ext>
+            </a:extLst>
+          </p:cNvPr>
+          <p:cNvSpPr>
+            <a:spLocks noGrp="1"/>
+          </p:cNvSpPr>
+          <p:nvPr>
+            <p:ph type="sldNum" sz="quarter" idx="12"/>
           </p:nvPr>
         </p:nvSpPr>
         <p:spPr/>
@@ -5523,7 +5512,7 @@
           <a:bodyPr wrap="square" lIns="73152" rIns="73152" anchor="t"/>
           <a:lstStyle/>
           <a:p>
-            <a:pPr algn="ctr">
+            <a:pPr algn="r">
               <a:spcAft>
                 <a:spcPts val="0"/>
               </a:spcAft>
@@ -5535,74 +5524,12 @@
               </a:defRPr>
             </a:pPr>
             <a:r>
-              <a:t>SCOPE</a:t>
-            </a:r>
-          </a:p>
-        </p:txBody>
-      </p:sp>
-      <p:sp>
-        <p:nvSpPr>
-          <p:cNvPr id="6" name="Slide Number Placeholder 5">
-            <a:extLst>
-              <a:ext uri="{FF2B5EF4-FFF2-40B4-BE49-F238E27FC236}">
-                <a16:creationId xmlns:a16="http://schemas.microsoft.com/office/drawing/2014/main" id="{EE16528B-72DB-0275-6A94-33ABB5CD7075}"/>
-              </a:ext>
-            </a:extLst>
-          </p:cNvPr>
-          <p:cNvSpPr>
-            <a:spLocks noGrp="1"/>
-          </p:cNvSpPr>
-          <p:nvPr>
-            <p:ph type="sldNum" sz="quarter" idx="12"/>
-          </p:nvPr>
-        </p:nvSpPr>
-        <p:spPr/>
-        <p:txBody>
-          <a:bodyPr wrap="square" lIns="73152" rIns="73152" anchor="t"/>
-          <a:lstStyle/>
-          <a:p>
-            <a:pPr algn="r">
-              <a:spcAft>
-                <a:spcPts val="0"/>
-              </a:spcAft>
-              <a:defRPr sz="1100" b="0">
-                <a:solidFill>
-                  <a:srgbClr val="64748B"/>
-                </a:solidFill>
-                <a:latin typeface="Calibri"/>
-              </a:defRPr>
-            </a:pPr>
-            <a:r>
               <a:t>2</a:t>
             </a:r>
             <a:endParaRPr lang="en-IN"/>
           </a:p>
         </p:txBody>
       </p:sp>
-      <p:pic>
-        <p:nvPicPr>
-          <p:cNvPr id="7" name="Picture 6" descr="guide_approval_email.png"/>
-          <p:cNvPicPr>
-            <a:picLocks noChangeAspect="1"/>
-          </p:cNvPicPr>
-          <p:nvPr/>
-        </p:nvPicPr>
-        <p:blipFill>
-          <a:blip r:embed="rId3"/>
-          <a:stretch>
-            <a:fillRect/>
-          </a:stretch>
-        </p:blipFill>
-        <p:spPr>
-          <a:xfrm>
-            <a:off x="673866" y="2653482"/>
-            <a:ext cx="11381493" cy="3296214"/>
-          </a:xfrm>
-          <a:prstGeom prst="rect">
-            <a:avLst/>
-          </a:prstGeom>
-        </p:spPr>
-      </p:pic>
     </p:spTree>
     <p:extLst>
       <p:ext uri="{BB962C8B-B14F-4D97-AF65-F5344CB8AC3E}">
@@ -6500,7 +6427,7 @@
           <p:nvPr/>
         </p:nvPicPr>
         <p:blipFill>
-          <a:blip r:embed="rId4"/>
+          <a:blip r:embed="rId2"/>
           <a:stretch>
             <a:fillRect/>
           </a:stretch>
@@ -7220,7 +7147,7 @@
           <a:noFill/>
         </p:spPr>
         <p:txBody>
-          <a:bodyPr wrap="square" rtlCol="0" lIns="73152" rIns="73152" anchor="t">
+          <a:bodyPr wrap="square" lIns="73152" rIns="73152" rtlCol="0" anchor="t">
             <a:spAutoFit/>
           </a:bodyPr>
           <a:lstStyle/>

</xml_diff>